<commit_message>
docs(deck): rework the network policy advisory to upstream Kubernetes and open source (S12)
</commit_message>
<xml_diff>
--- a/lgtm-presentation/Network-Policy-Process-Advisory.pptx
+++ b/lgtm-presentation/Network-Policy-Process-Advisory.pptx
@@ -521,7 +521,7 @@
           <a:lstStyle/>
           <a:p>
             <a:r>
-              <a:t>Welcome the audience and set context. This deck presents Red Hat's recommended approach for operationalizing in-cluster network segmentation on OpenShift. The customer's starting point is common: perimeter and east-west controls run through the firewall team on a traditional appliance, there is no in-cluster network policy, and developers have never written a firewall rule. The goal is not to pick tools or assign owners — it is to describe a process and a maturity path that the organization can adopt at its own pace. We will walk through where customers typically start, how to handle the developer skill gap, the CI/CD flow for policy changes, repo structure, day-two operations, the firewall team's evolving role, and what maturity looks like. Ask the audience: do you have a documented process for who authors, reviews, and approves network policies in your clusters today? The answer usually reveals the gap this deck fills.</a:t>
+              <a:t>Welcome the audience and set context. This deck presents a recommended approach for operationalizing in-cluster network segmentation on Kubernetes, with upstream APIs and open-source tools. The starting point is common: perimeter and east-west controls run through the firewall team on a traditional appliance, there is no in-cluster network policy, and developers have never written a firewall rule. The goal is not to pick tools or assign owners; it is to describe a process and a maturity path that the organization can adopt at its own pace. We will walk through where organizations typically start, how to handle the developer skill gap, the CI/CD flow for policy changes, repo structure, day-two operations, the firewall team's evolving role, and what maturity looks like. Ask the audience: do you have a documented process for who authors, reviews, and approves network policies in your clusters today? The answer usually reveals the gap this deck fills.</a:t>
             </a:r>
           </a:p>
         </p:txBody>
@@ -661,7 +661,7 @@
           <a:lstStyle/>
           <a:p>
             <a:r>
-              <a:t>Walk through the policy CI/CD pipeline. Every policy change — NetworkPolicy, ANP, BANP, EgressFirewall — flows through the same pipeline. Schema check with oc apply --dry-run=client catches invalid YAML and wrong API versions. Policy lint with conftest or kyverno CLI catches organizational policy violations like allow-all rules or missing labels. ACS build-time tools validate against known baselines and flag policies that would allow traffic outside the baseline. Platform or security team reviews the PR — CODEOWNERS enforces who reviews based on the file path. Merge triggers ArgoCD sync to staging, smoke tests validate connectivity, then sync to production. Post-deploy validation uses ACS network graph and OVN-K flow logs. Point to the diagram. The key principle: the CI pipeline is the only path to production. No exceptions, no emergency oc apply, no just this once.</a:t>
+              <a:t>Walk through the policy CI/CD pipeline. Every policy change (NetworkPolicy, ClusterNetworkPolicy, egress rules) flows through the same pipeline. Schema check with kubeconform and kubectl apply --dry-run=client catches invalid YAML and wrong API versions. Policy lint with conftest, kyverno test or Gatekeeper's gator verify catches organizational policy violations like allow-all rules or missing labels, and trivy config scans the manifests (its KSV-0038 check flags network policies without pod or namespace selectors). The baseline diff compares the change with the policy generated from observed flows and flags rules that would allow traffic outside the baseline. Platform or security team reviews the PR; CODEOWNERS enforces who reviews based on the file path. Merge triggers an Argo CD sync to staging, smoke tests validate connectivity, then sync to production. Post-deploy validation reads the Hubble or Calico flow logs, and Falco alerts on unexpected egress at runtime. Point to the diagram. The key principle: the CI pipeline is the only path to production. No exceptions, no emergency kubectl apply, no just this once.</a:t>
             </a:r>
           </a:p>
         </p:txBody>
@@ -731,7 +731,7 @@
           <a:lstStyle/>
           <a:p>
             <a:r>
-              <a:t>Describe the three-layer repository model. The platform-baselines directory contains ANP, BANP, and EgressFirewall resources — cluster-scoped policies authored by the platform team and reviewed by the firewall and security team. The onboarding directory contains starter NetworkPolicy templates per workload archetype — maintained by the platform team, consumed by app teams as starting points. The app-policies directory contains per-namespace NetworkPolicies authored by app teams, with base and overlay directories for Kustomize-based environment promotion. CODEOWNERS enforces review requirements by path: platform-baselines requires firewall team review, app-policies requires platform team review. This separation provides clear ownership boundaries. The same PR that modifies a policy flows through the same CI pipeline regardless of whether it targets dev, test, or production — only the Kustomize overlay differs.</a:t>
+              <a:t>Describe the three-layer repository model. The platform-baselines directory contains the ClusterNetworkPolicy resources of the Admin and Baseline tiers and the egress rules: cluster-scoped policies authored by the platform team and reviewed by the firewall and security team. The onboarding directory contains starter NetworkPolicy templates per workload archetype, maintained by the platform team and consumed by app teams as starting points. The app-policies directory contains per-namespace NetworkPolicies authored by app teams, with base and overlay directories for Kustomize-based environment promotion. CODEOWNERS enforces review requirements by path: platform-baselines requires firewall team review, app-policies requires platform team review. This separation provides clear ownership boundaries. The same PR that modifies a policy flows through the same CI pipeline regardless of whether it targets dev, test, or production; only the Kustomize overlay differs.</a:t>
             </a:r>
           </a:p>
         </p:txBody>
@@ -801,7 +801,7 @@
           <a:lstStyle/>
           <a:p>
             <a:r>
-              <a:t>Describe the three-team ownership model and point to the diagram. The firewall team authors EgressFirewall rules for external destinations, reviews all cluster-scoped policies (ANP, BANP) because they have cluster-wide blast radius, and continues to own the perimeter for north-south traffic, TLS inspection, and compliance logging. The platform team authors ANP and BANP guardrails, maintains starter templates, reviews app team NetworkPolicies, and owns the overall cluster security posture. App teams author namespace-scoped NetworkPolicy for their services, consume starter templates and ACS-generated baselines, and own their application's connectivity. The critical framing: the firewall team moves from approve every rule to set the boundaries and review the exceptions. This is faster for developers, safer for the organization, and a better use of the firewall team's expertise.</a:t>
+              <a:t>Describe the three-team ownership model and point to the diagram. The firewall team authors the egress rules for external destinations, reviews all cluster-scoped policies (the Admin and Baseline tiers) because they have cluster-wide blast radius, and continues to own the perimeter for north-south traffic, TLS inspection, and compliance logging. The platform team authors the ClusterNetworkPolicy guardrails, maintains starter templates, reviews app team NetworkPolicies, and owns the overall cluster security posture. App teams author namespace-scoped NetworkPolicy for their services, consume starter templates and generated baselines, and own their application's connectivity. The critical framing: the firewall team moves from approve every rule to set the boundaries and review the exceptions. This is faster for developers, safer for the organization, and a better use of the firewall team's expertise.</a:t>
             </a:r>
           </a:p>
         </p:txBody>
@@ -871,7 +871,7 @@
           <a:lstStyle/>
           <a:p>
             <a:r>
-              <a:t>Walk through the denied-flow triage process. When a developer reports my service cannot reach X, the first step is checking the ACS network graph for anomalous flows — was this connection ever in the baseline? If not, it was likely never policy-allowed, and the decision is whether to add a policy or investigate why the new connection exists. The second step is checking OVN-Kubernetes flow logs — these identify which tier denied the traffic: ANP, NetworkPolicy, or BANP. This tells you who needs to update the policy. If ANP denied it, the platform team needs to act. If a NetworkPolicy denied it, the app team needs to update their policy. If BANP denied it, no one wrote a policy for this connection at all. The third step is oc adm must-gather for offline analysis or escalation to Red Hat support. The target is under 30 minutes for triage. If it regularly takes longer, the observability tooling is not configured correctly.</a:t>
+              <a:t>Walk through the denied-flow triage process. When a developer reports my service cannot reach X, the first step is comparing with the observed baseline: was this connection ever in the generated policies kept in Git? If not, it was likely never policy-allowed, and the decision is whether to add a policy or investigate why the new connection exists. The second step is the flow logs: hubble observe with --verdict DROPPED on Cilium, or the Calico flow logs in Whisker, show the dropped flow with source pod, destination and port. Matching it to the policies that select the pod tells you which tier denied the traffic: Admin, NetworkPolicy, or Baseline. If the Admin tier denied it, the platform team needs to act. If a NetworkPolicy denied it, the app team updates their policy. If the Baseline tier denied it, no one wrote a policy for this connection at all. The third step is a diagnostics bundle, cilium sysdump or calicoctl cluster diags, for offline analysis, an upstream issue, or escalation to your support provider. The target is under 30 minutes for triage. If it regularly takes longer, the observability tooling is not configured correctly.</a:t>
             </a:r>
           </a:p>
         </p:txBody>
@@ -941,7 +941,7 @@
           <a:lstStyle/>
           <a:p>
             <a:r>
-              <a:t>Explain the break-glass process and drift detection. When a denied flow is blocking a production incident and the normal PR process is too slow, a platform team member creates a temporary ANP with a Pass rule at high priority. This is time-boxed with an expiration annotation and logged via an incident ticket. Within 24 hours, the proper policy change goes through the normal PR and CI pipeline, and the temporary rule is removed. All break-glass events are reviewed in the quarterly policy review. For drift detection: ArgoCD reports sync status for every policy manifest — if someone manually applies a policy, ArgoCD detects the drift and alerts or auto-reverts. ACS baseline drift catches new traffic flows that are outside the baseline, whether from policy changes or application changes. The critical lesson: define the break-glass process before you enforce anything in production. The first denied-flow incident without a break-glass process causes panic and a rollback of all policies.</a:t>
+              <a:t>Explain the break-glass process and drift detection. When a denied flow is blocking a production incident and the normal PR process is too slow, a platform team member creates a temporary Admin-tier ClusterNetworkPolicy with a Pass rule at high priority. This is time-boxed with an expiration annotation and logged via an incident ticket. If the Baseline tier is default-deny and no NetworkPolicy covers the target, a temporary NetworkPolicy is needed as well. Within 24 hours, the proper policy change goes through the normal PR and CI pipeline, and the temporary rule is removed. All break-glass events are reviewed in the quarterly policy review. For drift detection: Argo CD reports sync status for every policy manifest; if someone manually applies a policy, Argo CD detects the drift and alerts, or reverts it when self-heal is on. Baseline drift catches new traffic flows outside the observed baseline, whether from policy changes or application changes. The critical lesson: define the break-glass process before you enforce anything in production. The first denied-flow incident without a break-glass process causes panic and a rollback of all policies.</a:t>
             </a:r>
           </a:p>
         </p:txBody>
@@ -1011,7 +1011,7 @@
           <a:lstStyle/>
           <a:p>
             <a:r>
-              <a:t>Frame the firewall team's evolving role as elevation, not replacement. What stays with the firewall team: north-south edge controls on the perimeter firewall for TLS inspection, DDoS mitigation, and compliance logging. EgressFirewall authorship — the firewall team catalogs approved external destinations and authors EgressFirewall CRDs, which is their domain expertise. ANP and BANP review — the firewall team reviews all cluster-scoped policies because they have cluster-wide blast radius. What shifts to the platform and app teams: east-west traffic segmentation is handled by NetworkPolicy authored by app teams. The firewall team does not need to approve every pod-to-pod rule — that does not scale. The key framing for the customer: customers who presented in-cluster policy as a replacement for the firewall team met resistance. Customers who positioned it as the firewall team's expertise applied at a new layer got buy-in.</a:t>
+              <a:t>Frame the firewall team's evolving role as elevation, not replacement. What stays with the firewall team: north-south edge controls on the perimeter firewall for TLS inspection, DDoS mitigation, and compliance logging. Egress rule authorship: the firewall team catalogs approved external destinations and authors the egress rules, which is their domain expertise. Admin and Baseline tier review: the firewall team reviews all cluster-scoped policies because they have cluster-wide blast radius. What shifts to the platform and app teams: east-west traffic segmentation is handled by NetworkPolicy authored by app teams. The firewall team does not need to approve every pod-to-pod rule; that does not scale. The key framing: teams that presented in-cluster policy as a replacement for the firewall team met resistance. Teams that positioned it as the firewall team's expertise applied at a new layer got buy-in.</a:t>
             </a:r>
           </a:p>
         </p:txBody>
@@ -1081,7 +1081,7 @@
           <a:lstStyle/>
           <a:p>
             <a:r>
-              <a:t>Explain the EgressFirewall CRD. This is a per-project OpenShift resource that restricts outbound traffic from pods to external destinations. It supports both CIDR-based rules and DNS-based rules — the DNS capability is critical for external services that change IP addresses without notice. The firewall team's domain: they catalog approved external endpoints and author the EgressFirewall per namespace. This is a natural extension of what they already do at the perimeter — controlling which destinations workloads can reach — applied at the cluster level where the perimeter has no visibility. Combine EgressFirewall with NetworkPolicy: use NetworkPolicy for intra-cluster segmentation and EgressFirewall for external traffic control. They complement each other — NetworkPolicy controls east-west, EgressFirewall controls north-south from the pod perspective. Important caveat: use caution with DNS-based deny rules, as DNS resolution inconsistencies between nodes can cause unexpected behavior.</a:t>
+              <a:t>Explain egress control with upstream APIs. A ClusterNetworkPolicy in the Admin tier can carry egress rules whose peers are networks, CIDR ranges, which is part of the standard channel; deny everything outside the approved ranges and accept the approved ones. DNS names are harder: the domainNames peer of ClusterNetworkPolicy is in the experimental channel and only valid in Accept rules, and Calico's open-source edition has no DNS-based policy. On Cilium, a CiliumNetworkPolicy with toFQDNs gives DNS-based egress today, through Cilium's DNS proxy, which matters for external services that change IP addresses without notice. The firewall team's domain: they catalog approved external endpoints and author the egress rules. This extends what they already do at the perimeter, controlling which destinations workloads can reach, to the cluster level, where the perimeter has no visibility. Combine the two: NetworkPolicy for intra-cluster segmentation, cluster egress rules for external traffic control. Caveat: DNS-based rules depend on the DNS answers the cluster sees, so test them against the real resolvers.</a:t>
             </a:r>
           </a:p>
         </p:txBody>
@@ -1151,7 +1151,7 @@
           <a:lstStyle/>
           <a:p>
             <a:r>
-              <a:t>Walk through the maturity checklist. Default-deny in every namespace — no namespace without coverage. ACS baselines active — new flows trigger anomalous-flow alerts. ANP guardrails enforced — cross-environment traffic blocked, monitoring allowed, control-plane access restricted. BANP default-deny — the cluster-wide safety net catches any traffic not explicitly allowed. App teams authoring policies via PR — not oc apply. CI validates before merge — schema checks, policy linting, ACS build-time validation, and dry-run apply on every PR. EgressFirewall per project — outbound traffic restricted to approved destinations. Firewall team reviews not blocks — turnaround on ANP and BANP reviews is prompt. Denied-flow triage under 30 minutes. Quarterly policy review cadence covering break-glass events, stale policies, baseline refreshes, and RBAC audits. The maturity timeline is agreed upon by the organization — there is no universal pace.</a:t>
+              <a:t>Walk through the maturity checklist. Default-deny in every namespace: no namespace without coverage. Baselines reviewed: every production namespace has a reviewed baseline in Git, and new flows outside it raise alerts. Admin-tier guardrails enforced: cross-environment traffic blocked, monitoring allowed, control-plane access restricted. Baseline-tier default-deny: the cluster-wide safety net catches any traffic not explicitly allowed. App teams authoring policies via PR, not kubectl apply. CI validates before merge: schema checks, policy linting, the baseline diff, and dry-run apply on every PR. Egress rules restrict outbound traffic to approved destinations. Firewall team reviews, does not block: turnaround on Admin and Baseline tier reviews is prompt. Denied-flow triage under 30 minutes. Quarterly policy review cadence covering break-glass events, stale policies, baseline refreshes, and RBAC audits. The maturity timeline is agreed upon by the organization; there is no universal pace.</a:t>
             </a:r>
           </a:p>
         </p:txBody>
@@ -1221,7 +1221,7 @@
           <a:lstStyle/>
           <a:p>
             <a:r>
-              <a:t>Walk through the top five lessons from real customer engagements. First, customers who jumped to default-deny without ACS observation caused outages from denied traffic they did not know existed. The observation phase pays for itself. Second, the first set of starter templates should be simple — three to five archetypes, not twenty. Start broad and refine based on actual PR volume. Third, cataloging every external endpoint every service needs to reach is the most time-consuming part of the shift. Start this inventory in Phase 1 alongside ACS observation. Fourth, customers who presented in-cluster policy as a replacement for the firewall team met resistance. Customers who positioned it as the firewall team's expertise applied at a new layer got buy-in. Fifth, the first denied-flow incident in production without a break-glass process caused panic and a rollback of all policies. Define break-glass before you enforce. These lessons are from real engagements — they are patterns, not hypotheticals.</a:t>
+              <a:t>Walk through the top five lessons from real engagements. First, teams that jumped to default-deny without observing the flows caused outages from denied traffic they did not know existed. The observation phase pays for itself. Second, the first set of starter templates should be simple: three to five archetypes, not twenty. Start broad and refine based on actual PR volume. Third, cataloging every external endpoint every service needs to reach is the most time-consuming part of the shift. Start this inventory in Phase 1 alongside the flow observation. Fourth, teams that presented in-cluster policy as a replacement for the firewall team met resistance; teams that positioned it as the firewall team's expertise applied at a new layer got buy-in. Fifth, the first denied-flow incident in production without a break-glass process caused panic and a rollback of all policies. Define break-glass before you enforce. These lessons are from real engagements: they are patterns, not hypotheticals.</a:t>
             </a:r>
           </a:p>
         </p:txBody>
@@ -1291,7 +1291,7 @@
           <a:lstStyle/>
           <a:p>
             <a:r>
-              <a:t>Frame the customer's current state without judgment. The perimeter firewall handles everything — north-south and east-west traffic controls run through the firewall team on Palo Alto. There is no Kubernetes NetworkPolicy in the cluster. Developers are not security specialists — most have never written a firewall rule and do not inherently know what traffic their applications require. This is not unusual. Most organizations we work with started in exactly this position. The shift to in-cluster segmentation is not about replacing the firewall team or the perimeter — it is about extending the organization's security posture into a layer the perimeter cannot see. The perimeter firewall has no visibility into pod-to-pod traffic inside the cluster. A compromised pod behind the perimeter can reach every other pod unless the cluster itself enforces segmentation. That is the gap this process fills.</a:t>
+              <a:t>Frame the current state without judgment. The perimeter firewall handles everything: north-south and east-west traffic controls run through the firewall team on the perimeter appliance. There is no Kubernetes NetworkPolicy in the cluster. Developers are not security specialists; most have never written a firewall rule and do not inherently know what traffic their applications require. This is not unusual. Most organizations start in exactly this position. The shift to in-cluster segmentation is not about replacing the firewall team or the perimeter; it is about extending the organization's security posture into a layer the perimeter cannot see. The perimeter firewall has no visibility into pod-to-pod traffic inside the cluster. A compromised pod behind the perimeter can reach every other pod unless the cluster itself enforces segmentation. That is the gap this process fills.</a:t>
             </a:r>
           </a:p>
         </p:txBody>
@@ -1361,7 +1361,7 @@
           <a:lstStyle/>
           <a:p>
             <a:r>
-              <a:t>Point the audience to authoritative sources. The OpenShift AdminNetworkPolicy documentation covers the three-tier evaluation model and ANP syntax. The BaselineAdminNetworkPolicy page covers the cluster singleton safety net. The EgressFirewall documentation covers per-project egress control with CIDR and DNS rules. The ACS network policy management page covers baseline discovery, anomalous flow detection, and auto-generated policy YAML. The Kubernetes Network Policies documentation covers the standard NetworkPolicy API that app teams will author. The CNCF Cloud Native Security Whitepaper is the industry-consensus framework for cloud-native security posture. The companion document — Kubernetes Environment Access Policies — covers the broader governance framework including RBAC, admission control, GitOps, and audit that surrounds the network policy process described in this deck.</a:t>
+              <a:t>Point the audience to authoritative sources. The Network Policy API site covers ClusterNetworkPolicy, its Admin and Baseline tiers and the list of implementations. The v0.2.0 release notes record the move from AdminNetworkPolicy and BaselineAdminNetworkPolicy to ClusterNetworkPolicy and the Allow-to-Accept rename. The Calico 3.32 release notes and the Cilium network policy page say how each CNI enforces it. The Inspektor Gadget page covers generating NetworkPolicy from observed traffic. The Kubernetes Network Policies documentation covers the standard NetworkPolicy API that app teams will author. The companion document, Kubernetes Environment Access Policies, covers the broader governance framework including RBAC, admission control, GitOps, and audit that surrounds the network policy process described in this deck.</a:t>
             </a:r>
           </a:p>
         </p:txBody>
@@ -1431,7 +1431,7 @@
           <a:lstStyle/>
           <a:p>
             <a:r>
-              <a:t>Walk through the four phases. The most important point is that these are sequential and the timeline depends on the organization's complexity and risk tolerance. Phase 1 is observation — using ACS to discover what traffic actually flows before writing any policy. Phase 2 is baseline — applying default-deny and cleaning up ACS-generated policies. Phase 3 is guardrails — the platform team introduces cluster-scoped ANP and BANP rules that developers cannot override. Phase 4 is developer ownership — app teams author their own namespace-scoped NetworkPolicies via pull request. The most common failure we see is skipping Phase 1 and jumping straight to enforcement. Customers who did this caused outages from denied traffic they did not know existed. The observation phase pays for itself by revealing undocumented dependencies and unauthorized connections. Stress that each phase builds on the previous — you cannot do Phase 3 well without Phase 2's baseline, and Phase 2 is reckless without Phase 1's visibility.</a:t>
+              <a:t>Walk through the four phases. The most important point is that these are sequential and the timeline depends on the organization's complexity and risk tolerance. Phase 1 is observation: reading the CNI's flow logs to discover what traffic flows before writing any policy. Phase 2 is baseline: applying default-deny and cleaning up policies generated from the observed flows. Phase 3 is guardrails: the platform team introduces cluster-scoped ClusterNetworkPolicy rules in the Admin and Baseline tiers that developers cannot override. Phase 4 is developer ownership: app teams author their own namespace-scoped NetworkPolicies via pull request. The most common failure is skipping Phase 1 and jumping straight to enforcement; teams that did this caused outages from denied traffic they did not know existed. The observation phase pays for itself by revealing undocumented dependencies and unauthorized connections. Stress that each phase builds on the previous: you cannot do Phase 3 well without Phase 2's baseline, and Phase 2 is reckless without Phase 1's visibility.</a:t>
             </a:r>
           </a:p>
         </p:txBody>
@@ -1501,7 +1501,7 @@
           <a:lstStyle/>
           <a:p>
             <a:r>
-              <a:t>Explain what ACS does in the observation phase. Red Hat Advanced Cluster Security automatically discovers network flows between deployments, namespaces, and external destinations. It builds a network baseline — a map of every connection the cluster has seen — and renders it in the Network Graph. At this stage, nothing is denied. The goal is pure visibility. The firewall team and platform team review the ACS network graph together. They identify which services talk to each other and which should not, which services make outbound calls to external endpoints, which connections cross namespace boundaries, and which traffic patterns were previously invisible behind the perimeter. What we typically see: customers are surprised by the volume of east-west traffic they did not know existed. A frontend directly querying a database it should go through an API for. A monitoring agent making outbound calls to a SaaS endpoint. Discovery is the highest-value step.</a:t>
+              <a:t>Explain what observation means without a commercial console. The CNI already sees every flow. With Cilium, Hubble shows them (hubble observe, or the Hubble UI); with Calico 3.30 and later, Felix sends flow logs to Goldmane and the Whisker console shows them. Inspektor Gadget, a CNCF Sandbox project, adds the advise_networkpolicy gadget: it records the TCP and UDP traffic of the namespaces you choose and later turns it into NetworkPolicy YAML. At this stage, nothing is denied. The goal is pure visibility. The firewall team and platform team review the observed flows together. They identify which services talk to each other and which should not, which services make outbound calls to external endpoints, which connections cross namespace boundaries, and which traffic patterns were previously invisible behind the perimeter. What field teams typically see: organizations are surprised by the volume of east-west traffic they did not know existed. A frontend directly querying a database it should go through an API for. A monitoring agent making outbound calls to a SaaS endpoint. Discovery is the highest-value step.</a:t>
             </a:r>
           </a:p>
         </p:txBody>
@@ -1571,7 +1571,7 @@
           <a:lstStyle/>
           <a:p>
             <a:r>
-              <a:t>Walk through the baseline phase. The first action is applying default-deny NetworkPolicy in every namespace — podSelector empty, policyTypes Ingress and Egress. This is the single highest-impact security measure. Simultaneously, use ACS to auto-generate NetworkPolicy YAML from the observed baseline. ACS generates one policy per deployment, named stackrox-generated plus the deployment name, with ingress rules based on observed source pods and namespace selectors. These generated policies capture what traffic did flow, not what traffic should flow. The platform team reviews the generated policies, removes connections that should not have existed — and this audit step is extremely valuable — and applies the cleaned-up policies alongside the default-deny. The first default-deny rollout in a non-prod namespace immediately reveals undocumented dependencies: a monitoring agent scraping every pod, a legacy batch job connecting to an external database, a sidecar phoning home to a SaaS endpoint. Discovering these in dev or test is the point.</a:t>
+              <a:t>Walk through the baseline phase. The first action is applying default-deny NetworkPolicy in every namespace: podSelector empty, policyTypes Ingress and Egress. This is the single highest-impact security measure. Simultaneously, generate NetworkPolicy YAML from the observed flows. Inspektor Gadget's advise_networkpolicy writes one policy per workload, with ingress and egress rules based on the peers it saw; it can also write CiliumNetworkPolicy. On Calico, a StagedNetworkPolicy shows in the flow logs what a policy would deny before it is enforced. These generated policies capture what traffic did flow, not what traffic should flow. The platform team reviews them, removes connections that should not have existed, and applies the cleaned-up policies alongside the default-deny. This audit step finds the connections nobody documented. The first default-deny rollout in a non-prod namespace immediately reveals undocumented dependencies: a monitoring agent scraping every pod, a legacy batch job connecting to an external database, a sidecar phoning home to a SaaS endpoint. Discovering these in dev or test is the point.</a:t>
             </a:r>
           </a:p>
         </p:txBody>
@@ -1641,7 +1641,7 @@
           <a:lstStyle/>
           <a:p>
             <a:r>
-              <a:t>Explain the transition from platform-owned guardrails to developer ownership. In Phase 3, the platform team introduces AdminNetworkPolicy and BaselineAdminNetworkPolicy — cluster-scoped rules that developers cannot override. These enforce non-negotiable boundaries: deny cross-environment traffic, allow monitoring, restrict control-plane access. In Phase 4, app teams begin authoring their own namespace-scoped NetworkPolicies. The transition is gradual — developers start by reviewing ACS-generated baselines, then modify them, then eventually author from scratch as they build familiarity. The key architectural point: even if a developer writes no NetworkPolicies at all, the BANP safety net ensures default-deny behavior. This directly addresses the developer skill gap — the platform provides safety by default, and developers add precision as they learn. This is a fundamentally different model from asking every developer to be a firewall engineer.</a:t>
+              <a:t>Explain the transition from platform-owned guardrails to developer ownership. In Phase 3, the platform team introduces ClusterNetworkPolicy rules in the Admin and Baseline tiers: cluster-scoped rules that developers cannot override. They enforce non-negotiable boundaries: deny cross-environment traffic, accept monitoring, restrict control-plane access. In Phase 4, app teams begin authoring their own namespace-scoped NetworkPolicies. The transition is gradual: developers start by reviewing generated baselines, then modify them, then eventually author from scratch as they build familiarity. The key architectural point: even if a developer writes no NetworkPolicies at all, the Baseline-tier default-deny keeps the namespace closed. This directly addresses the developer skill gap: the platform provides safety by default, and developers add precision as they learn. This is a fundamentally different model from asking every developer to be a firewall engineer.</a:t>
             </a:r>
           </a:p>
         </p:txBody>
@@ -1711,7 +1711,7 @@
           <a:lstStyle/>
           <a:p>
             <a:r>
-              <a:t>This is the most important conceptual slide. OpenShift's OVN-Kubernetes network plugin evaluates traffic against three tiers of policy. Tier 1 is AdminNetworkPolicy — cluster-scoped, priority zero to ninety-nine, with Allow, Deny, or Pass actions. If the traffic matches an ANP Allow or Deny rule, tiers 2 and 3 are skipped entirely. If it matches a Pass rule, evaluation hands to tier 2. Tier 2 is standard Kubernetes NetworkPolicy — namespace-scoped, owned by app teams. Tier 3 is BaselineAdminNetworkPolicy — the cluster singleton safety net. BANP catches traffic that was passed by ANP and not matched by any NetworkPolicy. Point to the diagram showing the evaluation flow. The value proposition for the customer: the platform team controls tiers 1 and 3 — the guardrails. Developers control tier 2 — their application's policies. This separation of concerns is what makes the model scalable.</a:t>
+              <a:t>This is the most important conceptual slide. A CNI that implements the upstream ClusterNetworkPolicy API evaluates traffic against three tiers of policy. Tier 1 is the Admin tier: cluster-scoped, priority zero to one thousand, with Accept, Deny, or Pass actions. If the traffic matches an Admin Accept or Deny rule, tiers 2 and 3 are skipped entirely. If it matches a Pass rule, evaluation hands to tier 2. Tier 2 is standard Kubernetes NetworkPolicy: namespace-scoped, owned by app teams. Tier 3 is the Baseline tier, the safety net: it decides traffic that no Admin rule accepted or denied and that no NetworkPolicy covers. Point to the diagram showing the evaluation flow. The value proposition: the platform team controls tiers 1 and 3, the guardrails. Developers control tier 2, their application's policies. This separation of concerns is what makes the model scalable.</a:t>
             </a:r>
           </a:p>
         </p:txBody>
@@ -1781,7 +1781,12 @@
           <a:lstStyle/>
           <a:p>
             <a:r>
-              <a:t>Dive deeper into ANP and BANP. ANP enforces non-negotiable rules: deny traffic to the control plane from application namespaces, allow monitoring agents to scrape all pods, deny cross-environment traffic like dev to prod. A Pass rule explicitly delegates the decision to the NetworkPolicy tier — this is how the platform team says app teams, this one is yours to decide. BANP is the safety net configured as default-deny. If no ANP rule and no NetworkPolicy allows the traffic, BANP denies it. This means a namespace with no NetworkPolicies still has default-deny posture without requiring the app team to create it themselves. Critical caution: an ANP with an empty namespace selector matches all namespaces including openshift-star and kube-system. This can lock the cluster. Always use workload-specific label selectors. Best practice is to label application namespaces with a specific label and use that as the namespace selector in the ANP.</a:t>
+              <a:t>Dive deeper into the two cluster tiers. The Admin tier enforces non-negotiable rules: deny traffic to the control plane from application namespaces, accept monitoring agents scraping all pods, deny cross-environment traffic like dev to prod. A Pass rule explicitly delegates the decision to the NetworkPolicy tier: this is how the platform team says app teams, this one is yours to decide. The Baseline tier is the safety net, configured as default-deny. If no Admin rule and no NetworkPolicy allows the traffic, the Baseline tier denies it, so a namespace with no NetworkPolicies still has a default-deny posture without the app team creating it. Critical caution: an Admin-tier policy with an empty namespace selector matches all namespaces, including kube-system and the CNI's own namespaces. This can lock the cluster. Label application namespaces and use that label as the namespace selector.</a:t>
+            </a:r>
+          </a:p>
+          <a:p>
+            <a:r>
+              <a:t>Status, as of network-policy-api v0.2.0 (April 2026): ClusterNetworkPolicy is policy.networking.k8s.io/v1alpha2, an alpha API. It merged the earlier AdminNetworkPolicy and BaselineAdminNetworkPolicy (v1alpha1), which upstream now lists as previous APIs, and renamed Allow to Accept. Calico enforces it from 3.32 and no longer enforces the old pair; Cilium 1.20 enforces it behind the k8sClusterNetworkPolicy.enabled Helm value. Check the release notes before each upgrade.</a:t>
             </a:r>
           </a:p>
         </p:txBody>
@@ -1851,7 +1856,7 @@
           <a:lstStyle/>
           <a:p>
             <a:r>
-              <a:t>Walk through the four approaches for bridging the developer skill gap. First, ACS-generated baselines invert the skill requirement: developers review a generated policy, they do not author one from scratch. Reviewing a concrete policy — does this look right, should this connection exist — is dramatically easier than writing one from zero. Second, platform-authored starter templates for common workload archetypes — web-facing, internal API, batch job, database. Developers pick the template, customize the namespace and label selectors, and submit a PR. Third, BANP as a safety net converts missing policies from a security gap into a connectivity issue that surfaces immediately in testing. Fourth, golden-path namespace provisioning includes default-deny, EgressFirewall, starter templates, and RBAC bindings automatically — the developer starts with a secured namespace. They never see the everything-is-open starting point that leads to procrastination.</a:t>
+              <a:t>Walk through the four approaches for bridging the developer skill gap. First, generated baselines invert the skill requirement: developers review a policy generated from observed flows, they do not author one from scratch. Reviewing a concrete policy (does this look right, should this connection exist) is dramatically easier than writing one from zero. Second, platform-authored starter templates for common workload archetypes: web-facing, internal API, batch job, database. Developers pick the template, customize the namespace and label selectors, and submit a PR. Third, the Baseline tier as a safety net converts missing policies from a security gap into a connectivity issue that surfaces immediately in testing. Fourth, golden-path namespace provisioning includes default-deny, egress rules, starter templates, and RBAC bindings automatically; Kyverno's add-network-policy sample is a generate rule that creates the default-deny NetworkPolicy in every new namespace. The developer starts with a secured namespace and never sees the everything-is-open starting point that leads to procrastination.</a:t>
             </a:r>
           </a:p>
         </p:txBody>
@@ -4926,7 +4931,7 @@
                 </a:solidFill>
                 <a:latin typeface="Red Hat Text"/>
               </a:rPr>
-              <a:t>Red Hat Advisory — Shifting from perimeter to in-cluster segmentation.</a:t>
+              <a:t>Advisory — Shifting from perimeter to in-cluster segmentation.</a:t>
             </a:r>
           </a:p>
         </p:txBody>
@@ -5188,7 +5193,7 @@
         <p:spPr>
           <a:xfrm>
             <a:off x="566928" y="6364224"/>
-            <a:ext cx="300000" cy="250000"/>
+            <a:ext cx="914400" cy="250000"/>
           </a:xfrm>
           <a:prstGeom prst="rect">
             <a:avLst/>
@@ -5358,7 +5363,7 @@
                 </a:solidFill>
                 <a:latin typeface="Red Hat Text"/>
               </a:rPr>
-              <a:t>Schema check: oc apply --dry-run=client validates YAML and API version.</a:t>
+              <a:t>Schema check: kubeconform and kubectl apply --dry-run=client validate YAML and API version.</a:t>
             </a:r>
           </a:p>
           <a:p>
@@ -5374,7 +5379,7 @@
                 </a:solidFill>
                 <a:latin typeface="Red Hat Text"/>
               </a:rPr>
-              <a:t>Policy lint: conftest / kyverno CLI enforces organizational rules (no allow-all, required labels).</a:t>
+              <a:t>Policy lint: conftest / kyverno test / gator verify enforce organizational rules (no allow-all, required labels); trivy config scans the manifests.</a:t>
             </a:r>
           </a:p>
           <a:p>
@@ -5390,7 +5395,7 @@
                 </a:solidFill>
                 <a:latin typeface="Red Hat Text"/>
               </a:rPr>
-              <a:t>ACS build-time: validates against known baselines, flags traffic outside the baseline.</a:t>
+              <a:t>Baseline diff: compare the change with the policy generated from observed flows; flag traffic outside the baseline.</a:t>
             </a:r>
           </a:p>
           <a:p>
@@ -5406,7 +5411,7 @@
                 </a:solidFill>
                 <a:latin typeface="Red Hat Text"/>
               </a:rPr>
-              <a:t>Review: CODEOWNERS enforces — app teams author NP (platform reviews), platform authors ANP/BANP (firewall reviews).</a:t>
+              <a:t>Review: CODEOWNERS enforces — app teams author NP (platform reviews), platform authors ClusterNetworkPolicy (firewall reviews).</a:t>
             </a:r>
           </a:p>
         </p:txBody>
@@ -5427,8 +5432,8 @@
         </p:blipFill>
         <p:spPr>
           <a:xfrm>
-            <a:off x="2437516" y="4000000"/>
-            <a:ext cx="7058823" cy="2400000"/>
+            <a:off x="1993123" y="3017520"/>
+            <a:ext cx="8202705" cy="2788920"/>
           </a:xfrm>
           <a:prstGeom prst="rect">
             <a:avLst/>
@@ -5478,7 +5483,7 @@
         <p:spPr>
           <a:xfrm>
             <a:off x="566928" y="6364224"/>
-            <a:ext cx="300000" cy="250000"/>
+            <a:ext cx="914400" cy="250000"/>
           </a:xfrm>
           <a:prstGeom prst="rect">
             <a:avLst/>
@@ -5648,7 +5653,7 @@
                 </a:solidFill>
                 <a:latin typeface="Red Hat Text"/>
               </a:rPr>
-              <a:t>platform-baselines/ — ANP, BANP, EgressFirewall. Platform team authors, firewall/security team reviews. Cluster-wide scope.</a:t>
+              <a:t>platform-baselines/ — ClusterNetworkPolicy (Admin and Baseline tiers) and egress rules. Platform team authors, firewall/security team reviews. Cluster-wide scope.</a:t>
             </a:r>
           </a:p>
           <a:p>
@@ -5744,7 +5749,7 @@
         <p:spPr>
           <a:xfrm>
             <a:off x="566928" y="6364224"/>
-            <a:ext cx="300000" cy="250000"/>
+            <a:ext cx="914400" cy="250000"/>
           </a:xfrm>
           <a:prstGeom prst="rect">
             <a:avLst/>
@@ -5914,7 +5919,7 @@
                 </a:solidFill>
                 <a:latin typeface="Red Hat Text"/>
               </a:rPr>
-              <a:t>Firewall team: authors EgressFirewall, reviews ANP/BANP, owns perimeter (Palo Alto for north-south and compliance).</a:t>
+              <a:t>Firewall team: authors egress rules, reviews the Admin and Baseline tiers, owns the perimeter firewall (north-south and compliance).</a:t>
             </a:r>
           </a:p>
           <a:p>
@@ -5930,7 +5935,7 @@
                 </a:solidFill>
                 <a:latin typeface="Red Hat Text"/>
               </a:rPr>
-              <a:t>Platform team: authors ANP/BANP and starter templates, reviews app NetworkPolicies, owns cluster security posture.</a:t>
+              <a:t>Platform team: authors ClusterNetworkPolicy guardrails and starter templates, reviews app NetworkPolicies, owns cluster security posture.</a:t>
             </a:r>
           </a:p>
           <a:p>
@@ -5946,7 +5951,7 @@
                 </a:solidFill>
                 <a:latin typeface="Red Hat Text"/>
               </a:rPr>
-              <a:t>App teams: author namespace-scoped NetworkPolicy, consume templates and ACS baselines, own application connectivity.</a:t>
+              <a:t>App teams: author namespace-scoped NetworkPolicy, consume templates and generated baselines, own application connectivity.</a:t>
             </a:r>
           </a:p>
           <a:p>
@@ -5983,8 +5988,8 @@
         </p:blipFill>
         <p:spPr>
           <a:xfrm>
-            <a:off x="3396647" y="4000000"/>
-            <a:ext cx="5140562" cy="2400000"/>
+            <a:off x="3104822" y="3017520"/>
+            <a:ext cx="5979307" cy="2788920"/>
           </a:xfrm>
           <a:prstGeom prst="rect">
             <a:avLst/>
@@ -6034,7 +6039,7 @@
         <p:spPr>
           <a:xfrm>
             <a:off x="566928" y="6364224"/>
-            <a:ext cx="300000" cy="250000"/>
+            <a:ext cx="914400" cy="250000"/>
           </a:xfrm>
           <a:prstGeom prst="rect">
             <a:avLst/>
@@ -6204,7 +6209,7 @@
                 </a:solidFill>
                 <a:latin typeface="Red Hat Text"/>
               </a:rPr>
-              <a:t>Step 1: check ACS network graph for anomalous flows — was this connection ever in the baseline?</a:t>
+              <a:t>Step 1: compare with the observed baseline — was this connection ever in the generated policies in Git?</a:t>
             </a:r>
           </a:p>
           <a:p>
@@ -6220,7 +6225,7 @@
                 </a:solidFill>
                 <a:latin typeface="Red Hat Text"/>
               </a:rPr>
-              <a:t>Step 2: check OVN-Kubernetes flow logs — which tier (ANP, NP, or BANP) denied the traffic? This tells you who needs to update the policy.</a:t>
+              <a:t>Step 2: read the flow logs (hubble observe --verdict DROPPED, or Calico's flow logs) and match the dropped flow to the policies that select the pod: which tier (Admin, NP, or Baseline) denied it tells you who updates the policy.</a:t>
             </a:r>
           </a:p>
           <a:p>
@@ -6236,7 +6241,7 @@
                 </a:solidFill>
                 <a:latin typeface="Red Hat Text"/>
               </a:rPr>
-              <a:t>Step 3: oc adm must-gather — collects network policy state, OVN-K configuration, and flow logs for offline analysis or Red Hat support escalation.</a:t>
+              <a:t>Step 3: cilium sysdump or calicoctl cluster diags collects policy state, CNI configuration, and logs for offline analysis or escalation.</a:t>
             </a:r>
           </a:p>
           <a:p>
@@ -6286,7 +6291,7 @@
                 </a:solidFill>
                 <a:latin typeface="Red Hat Text"/>
               </a:rPr>
-              <a:t>OVN-K logs identify which tier denied the traffic.</a:t>
+              <a:t>The flow logs and the tier that matched say who owns the fix.</a:t>
             </a:r>
           </a:p>
         </p:txBody>
@@ -6300,7 +6305,7 @@
         <p:spPr>
           <a:xfrm>
             <a:off x="566928" y="6364224"/>
-            <a:ext cx="300000" cy="250000"/>
+            <a:ext cx="914400" cy="250000"/>
           </a:xfrm>
           <a:prstGeom prst="rect">
             <a:avLst/>
@@ -6470,7 +6475,7 @@
                 </a:solidFill>
                 <a:latin typeface="Red Hat Text"/>
               </a:rPr>
-              <a:t>Break-glass: platform team creates a temporary ANP Pass rule at high priority, time-boxed with an expiration annotation, logged via incident ticket. Proper policy change follows within 24 hours via normal PR.</a:t>
+              <a:t>Break-glass: platform team creates a temporary Admin-tier Pass rule at high priority, time-boxed with an expiration annotation, logged via incident ticket. Proper policy change follows within 24 hours via normal PR.</a:t>
             </a:r>
           </a:p>
           <a:p>
@@ -6486,7 +6491,7 @@
                 </a:solidFill>
                 <a:latin typeface="Red Hat Text"/>
               </a:rPr>
-              <a:t>ArgoCD drift detection: if someone manually applies a policy via oc apply instead of the PR pipeline, ArgoCD detects the drift and alerts or auto-reverts.</a:t>
+              <a:t>Argo CD drift detection: if someone manually applies a policy via kubectl apply instead of the PR pipeline, Argo CD detects the drift and alerts or reverts it (self-heal).</a:t>
             </a:r>
           </a:p>
           <a:p>
@@ -6502,7 +6507,7 @@
                 </a:solidFill>
                 <a:latin typeface="Red Hat Text"/>
               </a:rPr>
-              <a:t>ACS baseline drift: new traffic flows outside the baseline trigger anomalous-flow alerts — catches both policy drift and application drift.</a:t>
+              <a:t>Baseline drift: new flows outside the observed baseline show up in the flow logs and Falco alerts — catches both policy drift and application drift.</a:t>
             </a:r>
           </a:p>
           <a:p>
@@ -6566,7 +6571,7 @@
         <p:spPr>
           <a:xfrm>
             <a:off x="566928" y="6364224"/>
-            <a:ext cx="300000" cy="250000"/>
+            <a:ext cx="914400" cy="250000"/>
           </a:xfrm>
           <a:prstGeom prst="rect">
             <a:avLst/>
@@ -6736,7 +6741,7 @@
                 </a:solidFill>
                 <a:latin typeface="Red Hat Text"/>
               </a:rPr>
-              <a:t>What stays: north-south edge controls (Palo Alto for TLS inspection, DDoS, compliance logging), EgressFirewall authorship (approved CIDRs, DNS rules), ANP/BANP review (cluster-wide blast radius).</a:t>
+              <a:t>What stays: north-south edge controls (the perimeter firewall for TLS inspection, DDoS, compliance logging), egress rule authorship (approved CIDRs, DNS rules), Admin and Baseline tier review (cluster-wide blast radius).</a:t>
             </a:r>
           </a:p>
           <a:p>
@@ -6784,7 +6789,7 @@
                 </a:solidFill>
                 <a:latin typeface="Red Hat Text"/>
               </a:rPr>
-              <a:t>Customers who presented in-cluster policy as a replacement met resistance. Customers who positioned it as the firewall team's expertise at a new layer got buy-in.</a:t>
+              <a:t>Teams that presented in-cluster policy as a replacement met resistance. Teams that positioned it as the firewall team's expertise at a new layer got buy-in.</a:t>
             </a:r>
           </a:p>
         </p:txBody>
@@ -6832,7 +6837,7 @@
         <p:spPr>
           <a:xfrm>
             <a:off x="566928" y="6364224"/>
-            <a:ext cx="300000" cy="250000"/>
+            <a:ext cx="914400" cy="250000"/>
           </a:xfrm>
           <a:prstGeom prst="rect">
             <a:avLst/>
@@ -6928,7 +6933,7 @@
                 </a:solidFill>
                 <a:latin typeface="Red Hat Text"/>
               </a:rPr>
-              <a:t>EGRESSFIREWALL</a:t>
+              <a:t>EGRESS</a:t>
             </a:r>
           </a:p>
         </p:txBody>
@@ -7002,7 +7007,7 @@
                 </a:solidFill>
                 <a:latin typeface="Red Hat Text"/>
               </a:rPr>
-              <a:t>EgressFirewall is a per-project OpenShift CRD that restricts outbound traffic from pods to external destinations.</a:t>
+              <a:t>Admin-tier ClusterNetworkPolicy egress rules with networks peers (CIDR, standard channel) restrict outbound traffic cluster-wide.</a:t>
             </a:r>
           </a:p>
           <a:p>
@@ -7018,7 +7023,7 @@
                 </a:solidFill>
                 <a:latin typeface="Red Hat Text"/>
               </a:rPr>
-              <a:t>Supports both CIDR-based and DNS-based rules — critical for external services that change IP addresses without notice.</a:t>
+              <a:t>DNS-based rules: CNP domainNames peers are experimental and Accept-only; Cilium's toFQDNs (CiliumNetworkPolicy) gives DNS-based egress today.</a:t>
             </a:r>
           </a:p>
           <a:p>
@@ -7034,7 +7039,7 @@
                 </a:solidFill>
                 <a:latin typeface="Red Hat Text"/>
               </a:rPr>
-              <a:t>The firewall team's domain: they catalog approved external endpoints and author the EgressFirewall per namespace.</a:t>
+              <a:t>The firewall team's domain: they catalog approved external endpoints and author the egress rules per environment.</a:t>
             </a:r>
           </a:p>
           <a:p>
@@ -7050,7 +7055,7 @@
                 </a:solidFill>
                 <a:latin typeface="Red Hat Text"/>
               </a:rPr>
-              <a:t>Combine with NetworkPolicy: use NetworkPolicy for intra-cluster segmentation and EgressFirewall for external traffic control. They complement each other.</a:t>
+              <a:t>Combine with NetworkPolicy: NetworkPolicy for intra-cluster segmentation, cluster egress rules for external traffic control. They complement each other.</a:t>
             </a:r>
           </a:p>
         </p:txBody>
@@ -7098,7 +7103,7 @@
         <p:spPr>
           <a:xfrm>
             <a:off x="566928" y="6364224"/>
-            <a:ext cx="300000" cy="250000"/>
+            <a:ext cx="914400" cy="250000"/>
           </a:xfrm>
           <a:prstGeom prst="rect">
             <a:avLst/>
@@ -7284,7 +7289,7 @@
                 </a:solidFill>
                 <a:latin typeface="Red Hat Text"/>
               </a:rPr>
-              <a:t>ACS baselines active — new flows trigger anomalous-flow alerts.</a:t>
+              <a:t>Baselines reviewed — new flows outside them raise alerts.</a:t>
             </a:r>
           </a:p>
           <a:p>
@@ -7300,7 +7305,7 @@
                 </a:solidFill>
                 <a:latin typeface="Red Hat Text"/>
               </a:rPr>
-              <a:t>ANP guardrails enforced — cross-environment traffic blocked, monitoring allowed.</a:t>
+              <a:t>Admin-tier guardrails enforced — cross-environment traffic blocked, monitoring allowed.</a:t>
             </a:r>
           </a:p>
           <a:p>
@@ -7316,7 +7321,7 @@
                 </a:solidFill>
                 <a:latin typeface="Red Hat Text"/>
               </a:rPr>
-              <a:t>BANP default-deny — the cluster-wide safety net catches unmatched traffic.</a:t>
+              <a:t>Baseline-tier default-deny — the cluster-wide safety net catches unmatched traffic.</a:t>
             </a:r>
           </a:p>
           <a:p>
@@ -7332,7 +7337,7 @@
                 </a:solidFill>
                 <a:latin typeface="Red Hat Text"/>
               </a:rPr>
-              <a:t>App teams authoring policies via PR — not oc apply.</a:t>
+              <a:t>App teams authoring policies via PR — not kubectl apply.</a:t>
             </a:r>
           </a:p>
           <a:p>
@@ -7348,7 +7353,7 @@
                 </a:solidFill>
                 <a:latin typeface="Red Hat Text"/>
               </a:rPr>
-              <a:t>CI validates before merge — schema, lint, ACS, dry-run on every PR.</a:t>
+              <a:t>CI validates before merge — schema, lint, baseline diff, dry-run on every PR.</a:t>
             </a:r>
           </a:p>
           <a:p>
@@ -7364,7 +7369,7 @@
                 </a:solidFill>
                 <a:latin typeface="Red Hat Text"/>
               </a:rPr>
-              <a:t>EgressFirewall per project — outbound traffic restricted to approved destinations.</a:t>
+              <a:t>Egress rules per environment — outbound traffic restricted to approved destinations.</a:t>
             </a:r>
           </a:p>
           <a:p>
@@ -7428,7 +7433,7 @@
         <p:spPr>
           <a:xfrm>
             <a:off x="566928" y="6364224"/>
-            <a:ext cx="300000" cy="250000"/>
+            <a:ext cx="914400" cy="250000"/>
           </a:xfrm>
           <a:prstGeom prst="rect">
             <a:avLst/>
@@ -7558,7 +7563,7 @@
                 </a:solidFill>
                 <a:latin typeface="Overpass SemiBold"/>
               </a:rPr>
-              <a:t>What customers wish they'd done</a:t>
+              <a:t>What teams wish they'd done</a:t>
             </a:r>
           </a:p>
         </p:txBody>
@@ -7598,7 +7603,7 @@
                 </a:solidFill>
                 <a:latin typeface="Red Hat Text"/>
               </a:rPr>
-              <a:t>1. 'We should have started with observation, not enforcement.' Jumping to default-deny without ACS observation caused outages from denied traffic they didn't know existed.</a:t>
+              <a:t>1. 'We should have started with observation, not enforcement.' Jumping to default-deny without observing the flows caused outages from denied traffic they didn't know existed.</a:t>
             </a:r>
           </a:p>
           <a:p>
@@ -7630,7 +7635,7 @@
                 </a:solidFill>
                 <a:latin typeface="Red Hat Text"/>
               </a:rPr>
-              <a:t>3. 'We underestimated the EgressFirewall work.' Cataloging every external endpoint is the most time-consuming part. Start this inventory in Phase 1.</a:t>
+              <a:t>3. 'We underestimated the egress work.' Cataloging every external endpoint is the most time-consuming part. Start this inventory in Phase 1.</a:t>
             </a:r>
           </a:p>
           <a:p>
@@ -7696,7 +7701,7 @@
                 </a:solidFill>
                 <a:latin typeface="Red Hat Text"/>
               </a:rPr>
-              <a:t>These lessons come from real customer engagements.</a:t>
+              <a:t>These lessons come from real engagements.</a:t>
             </a:r>
           </a:p>
         </p:txBody>
@@ -7710,7 +7715,7 @@
         <p:spPr>
           <a:xfrm>
             <a:off x="566928" y="6364224"/>
-            <a:ext cx="300000" cy="250000"/>
+            <a:ext cx="914400" cy="250000"/>
           </a:xfrm>
           <a:prstGeom prst="rect">
             <a:avLst/>
@@ -7896,7 +7901,7 @@
                 </a:solidFill>
                 <a:latin typeface="Red Hat Text"/>
               </a:rPr>
-              <a:t>The organization wants to shift network segmentation left into the cluster — NetworkPolicy, AdminNetworkPolicy, EgressFirewall — but hasn't defined the workflow.</a:t>
+              <a:t>The organization wants to shift network segmentation left into the cluster (NetworkPolicy, ClusterNetworkPolicy, egress rules) but has not defined the workflow.</a:t>
             </a:r>
           </a:p>
           <a:p>
@@ -7962,7 +7967,7 @@
                 </a:solidFill>
                 <a:latin typeface="Red Hat Text"/>
               </a:rPr>
-              <a:t>This is Red Hat's recommended approach based on customer engagements.</a:t>
+              <a:t>A recommended approach, built on upstream Kubernetes and open-source tools.</a:t>
             </a:r>
           </a:p>
         </p:txBody>
@@ -7976,7 +7981,7 @@
         <p:spPr>
           <a:xfrm>
             <a:off x="566928" y="6364224"/>
-            <a:ext cx="300000" cy="250000"/>
+            <a:ext cx="914400" cy="250000"/>
           </a:xfrm>
           <a:prstGeom prst="rect">
             <a:avLst/>
@@ -8146,7 +8151,7 @@
                 </a:solidFill>
                 <a:latin typeface="Red Hat Text"/>
               </a:rPr>
-              <a:t>OpenShift AdminNetworkPolicy — docs.redhat.com/openshift_container_platform/4.18/html/network_security/admin-network-policy</a:t>
+              <a:t>Network Policy API (ClusterNetworkPolicy) — network-policy-api.sigs.k8s.io</a:t>
             </a:r>
           </a:p>
           <a:p>
@@ -8162,7 +8167,7 @@
                 </a:solidFill>
                 <a:latin typeface="Red Hat Text"/>
               </a:rPr>
-              <a:t>BaselineAdminNetworkPolicy — docs.openshift.com/container-platform/4.16/.../ovn-k-banp.html</a:t>
+              <a:t>network-policy-api v0.2.0 release — github.com/kubernetes-sigs/network-policy-api/releases/tag/v0.2.0</a:t>
             </a:r>
           </a:p>
           <a:p>
@@ -8178,7 +8183,7 @@
                 </a:solidFill>
                 <a:latin typeface="Red Hat Text"/>
               </a:rPr>
-              <a:t>OpenShift EgressFirewall — docs.redhat.com/openshift_container_platform/4.18/html/network_security/egress-firewall</a:t>
+              <a:t>Calico ClusterNetworkPolicy (v3.32 release notes) — github.com/projectcalico/calico, release-notes/v3.32.0-release-notes.md</a:t>
             </a:r>
           </a:p>
           <a:p>
@@ -8194,7 +8199,7 @@
                 </a:solidFill>
                 <a:latin typeface="Red Hat Text"/>
               </a:rPr>
-              <a:t>ACS network policies — docs.redhat.com/red_hat_advanced_cluster_security_for_kubernetes/3.69/html/operating/manage-network-policies</a:t>
+              <a:t>Cilium network policy — docs.cilium.io/en/stable/network/kubernetes/policy/</a:t>
             </a:r>
           </a:p>
           <a:p>
@@ -8210,7 +8215,7 @@
                 </a:solidFill>
                 <a:latin typeface="Red Hat Text"/>
               </a:rPr>
-              <a:t>Kubernetes Network Policies — kubernetes.io/docs/concepts/services-networking/network-policies/</a:t>
+              <a:t>Inspektor Gadget advise_networkpolicy — inspektor-gadget.io/docs/latest/gadgets/advise_networkpolicy</a:t>
             </a:r>
           </a:p>
           <a:p>
@@ -8226,7 +8231,7 @@
                 </a:solidFill>
                 <a:latin typeface="Red Hat Text"/>
               </a:rPr>
-              <a:t>CNCF Cloud Native Security Whitepaper — github.com/cncf/tag-security</a:t>
+              <a:t>Kubernetes Network Policies — kubernetes.io/docs/concepts/services-networking/network-policies/</a:t>
             </a:r>
           </a:p>
           <a:p>
@@ -8256,7 +8261,7 @@
         <p:spPr>
           <a:xfrm>
             <a:off x="566928" y="6364224"/>
-            <a:ext cx="300000" cy="250000"/>
+            <a:ext cx="914400" cy="250000"/>
           </a:xfrm>
           <a:prstGeom prst="rect">
             <a:avLst/>
@@ -8386,7 +8391,7 @@
                 </a:solidFill>
                 <a:latin typeface="Overpass SemiBold"/>
               </a:rPr>
-              <a:t>The four-phase journey</a:t>
+              <a:t>The four-phase maturity path</a:t>
             </a:r>
           </a:p>
         </p:txBody>
@@ -8426,7 +8431,7 @@
                 </a:solidFill>
                 <a:latin typeface="Red Hat Text"/>
               </a:rPr>
-              <a:t>Phase 1 — Observe: understand what traffic actually flows today using ACS network graph. No enforcement yet.</a:t>
+              <a:t>Phase 1 — Observe: understand what traffic flows today from the CNI's flow logs (Hubble or Calico). No enforcement yet.</a:t>
             </a:r>
           </a:p>
           <a:p>
@@ -8442,7 +8447,7 @@
                 </a:solidFill>
                 <a:latin typeface="Red Hat Text"/>
               </a:rPr>
-              <a:t>Phase 2 — Baseline: apply default-deny in every namespace, auto-generate policies from ACS baselines, clean up observed flows.</a:t>
+              <a:t>Phase 2 — Baseline: apply default-deny in every namespace, generate policies from the observed flows, clean them up.</a:t>
             </a:r>
           </a:p>
           <a:p>
@@ -8458,7 +8463,7 @@
                 </a:solidFill>
                 <a:latin typeface="Red Hat Text"/>
               </a:rPr>
-              <a:t>Phase 3 — Guardrails: introduce cluster-scoped ANP and BANP policies owned by the platform team.</a:t>
+              <a:t>Phase 3 — Guardrails: introduce cluster-scoped ClusterNetworkPolicy (Admin and Baseline tiers) owned by the platform team.</a:t>
             </a:r>
           </a:p>
           <a:p>
@@ -8538,7 +8543,7 @@
         <p:spPr>
           <a:xfrm>
             <a:off x="566928" y="6364224"/>
-            <a:ext cx="300000" cy="250000"/>
+            <a:ext cx="914400" cy="250000"/>
           </a:xfrm>
           <a:prstGeom prst="rect">
             <a:avLst/>
@@ -8668,7 +8673,7 @@
                 </a:solidFill>
                 <a:latin typeface="Overpass SemiBold"/>
               </a:rPr>
-              <a:t>Observe with ACS</a:t>
+              <a:t>Observe the flows</a:t>
             </a:r>
           </a:p>
         </p:txBody>
@@ -8708,7 +8713,7 @@
                 </a:solidFill>
                 <a:latin typeface="Red Hat Text"/>
               </a:rPr>
-              <a:t>ACS automatically discovers network flows between deployments, namespaces, and external destinations and builds a network baseline.</a:t>
+              <a:t>The CNI records flows between pods, namespaces, and external destinations: Hubble with Cilium, flow logs (Goldmane, Whisker) with Calico.</a:t>
             </a:r>
           </a:p>
           <a:p>
@@ -8724,7 +8729,7 @@
                 </a:solidFill>
                 <a:latin typeface="Red Hat Text"/>
               </a:rPr>
-              <a:t>The Network Graph renders every connection the cluster has seen — the source of truth for what traffic is expected.</a:t>
+              <a:t>Inspektor Gadget's advise_networkpolicy gadget records the TCP and UDP traffic of chosen namespaces. Together they give the network baseline, the source of truth for what traffic is expected.</a:t>
             </a:r>
           </a:p>
           <a:p>
@@ -8740,7 +8745,7 @@
                 </a:solidFill>
                 <a:latin typeface="Red Hat Text"/>
               </a:rPr>
-              <a:t>The firewall team and platform team review the graph together and identify which services talk to each other, which make outbound calls, and which cross namespace boundaries.</a:t>
+              <a:t>The firewall team and platform team review the flows together and identify which services talk to each other, which make outbound calls, and which cross namespace boundaries.</a:t>
             </a:r>
           </a:p>
           <a:p>
@@ -8756,7 +8761,7 @@
                 </a:solidFill>
                 <a:latin typeface="Red Hat Text"/>
               </a:rPr>
-              <a:t>What Red Hat typically sees: customers are surprised by the volume of east-west traffic that was invisible behind the perimeter.</a:t>
+              <a:t>What field teams typically see: organizations are surprised by the volume of east-west traffic that was invisible behind the perimeter.</a:t>
             </a:r>
           </a:p>
         </p:txBody>
@@ -8804,7 +8809,7 @@
         <p:spPr>
           <a:xfrm>
             <a:off x="566928" y="6364224"/>
-            <a:ext cx="300000" cy="250000"/>
+            <a:ext cx="914400" cy="250000"/>
           </a:xfrm>
           <a:prstGeom prst="rect">
             <a:avLst/>
@@ -8934,7 +8939,7 @@
                 </a:solidFill>
                 <a:latin typeface="Overpass SemiBold"/>
               </a:rPr>
-              <a:t>Baseline: default-deny + ACS policies</a:t>
+              <a:t>Baseline: default-deny + generated policies</a:t>
             </a:r>
           </a:p>
         </p:txBody>
@@ -8990,7 +8995,7 @@
                 </a:solidFill>
                 <a:latin typeface="Red Hat Text"/>
               </a:rPr>
-              <a:t>Use ACS to auto-generate NetworkPolicy YAML from observed baselines. Each policy is named stackrox-generated-&lt;deployment&gt; with ingress rules from observed source pods.</a:t>
+              <a:t>Generate NetworkPolicy YAML from the observed flows: advise_networkpolicy writes one policy per workload, with rules from the observed peers.</a:t>
             </a:r>
           </a:p>
           <a:p>
@@ -9056,7 +9061,7 @@
                 </a:solidFill>
                 <a:latin typeface="Red Hat Text"/>
               </a:rPr>
-              <a:t>ACS-generated policies are a starting point, not the final state.</a:t>
+              <a:t>Generated policies are a starting point, not the final state.</a:t>
             </a:r>
           </a:p>
         </p:txBody>
@@ -9070,7 +9075,7 @@
         <p:spPr>
           <a:xfrm>
             <a:off x="566928" y="6364224"/>
-            <a:ext cx="300000" cy="250000"/>
+            <a:ext cx="914400" cy="250000"/>
           </a:xfrm>
           <a:prstGeom prst="rect">
             <a:avLst/>
@@ -9240,7 +9245,7 @@
                 </a:solidFill>
                 <a:latin typeface="Red Hat Text"/>
               </a:rPr>
-              <a:t>Phase 3: the platform team introduces cluster-scoped guardrails using AdminNetworkPolicy (ANP) and BaselineAdminNetworkPolicy (BANP). These are the policies developers cannot override.</a:t>
+              <a:t>Phase 3: the platform team introduces cluster-scoped guardrails with ClusterNetworkPolicy, in its Admin and Baseline tiers. These are the policies developers cannot override.</a:t>
             </a:r>
           </a:p>
           <a:p>
@@ -9272,7 +9277,7 @@
                 </a:solidFill>
                 <a:latin typeface="Red Hat Text"/>
               </a:rPr>
-              <a:t>The transition from Phase 3 to Phase 4 is gradual — developers start by reviewing ACS-generated baselines, then modify them, then eventually author from scratch.</a:t>
+              <a:t>The transition from Phase 3 to Phase 4 is gradual — developers start by reviewing generated baselines, then modify them, then eventually author from scratch.</a:t>
             </a:r>
           </a:p>
           <a:p>
@@ -9288,7 +9293,7 @@
                 </a:solidFill>
                 <a:latin typeface="Red Hat Text"/>
               </a:rPr>
-              <a:t>The platform team controls the guardrails. Developers control their application connectivity. Even if a developer writes no policies at all, the BANP safety net ensures default-deny.</a:t>
+              <a:t>The platform team controls the guardrails. Developers control their application connectivity. Even if a developer writes no policies at all, the Baseline tier ensures default-deny.</a:t>
             </a:r>
           </a:p>
         </p:txBody>
@@ -9322,7 +9327,7 @@
                 </a:solidFill>
                 <a:latin typeface="Red Hat Text"/>
               </a:rPr>
-              <a:t>BANP addresses the developer skill gap directly — safety by default.</a:t>
+              <a:t>The Baseline tier addresses the developer skill gap directly: safety by default.</a:t>
             </a:r>
           </a:p>
         </p:txBody>
@@ -9336,7 +9341,7 @@
         <p:spPr>
           <a:xfrm>
             <a:off x="566928" y="6364224"/>
-            <a:ext cx="300000" cy="250000"/>
+            <a:ext cx="914400" cy="250000"/>
           </a:xfrm>
           <a:prstGeom prst="rect">
             <a:avLst/>
@@ -9506,7 +9511,7 @@
                 </a:solidFill>
                 <a:latin typeface="Red Hat Text"/>
               </a:rPr>
-              <a:t>Tier 1 — AdminNetworkPolicy (ANP): cluster-scoped, priority 0-99, Allow/Deny/Pass. Cannot be overridden by tenants.</a:t>
+              <a:t>Tier 1 — ClusterNetworkPolicy, Admin tier: cluster-scoped, priority 0-1000, Accept/Deny/Pass. Cannot be overridden by tenants.</a:t>
             </a:r>
           </a:p>
           <a:p>
@@ -9522,7 +9527,7 @@
                 </a:solidFill>
                 <a:latin typeface="Red Hat Text"/>
               </a:rPr>
-              <a:t>Tier 2 — NetworkPolicy (NP): namespace-scoped, owned by app teams. Only evaluated if ANP passed the traffic.</a:t>
+              <a:t>Tier 2 — NetworkPolicy (NP): namespace-scoped, owned by app teams. Evaluated unless an Admin rule accepted or denied it.</a:t>
             </a:r>
           </a:p>
           <a:p>
@@ -9538,7 +9543,7 @@
                 </a:solidFill>
                 <a:latin typeface="Red Hat Text"/>
               </a:rPr>
-              <a:t>Tier 3 — BaselineAdminNetworkPolicy (BANP): cluster singleton, safety net. Overridable by NetworkPolicy.</a:t>
+              <a:t>Tier 3 — ClusterNetworkPolicy, Baseline tier: cluster-scoped safety net. Overridable by NetworkPolicy.</a:t>
             </a:r>
           </a:p>
           <a:p>
@@ -9554,7 +9559,7 @@
                 </a:solidFill>
                 <a:latin typeface="Red Hat Text"/>
               </a:rPr>
-              <a:t>ANP Allow/Deny are final — NP and BANP are skipped. ANP Pass hands evaluation to the next tier.</a:t>
+              <a:t>Admin Accept/Deny are final — NP and the Baseline tier are skipped. Admin Pass hands evaluation to the next tier.</a:t>
             </a:r>
           </a:p>
         </p:txBody>
@@ -9575,8 +9580,8 @@
         </p:blipFill>
         <p:spPr>
           <a:xfrm>
-            <a:off x="3716049" y="4000000"/>
-            <a:ext cx="4501758" cy="2400000"/>
+            <a:off x="3481030" y="3017520"/>
+            <a:ext cx="5226891" cy="2788920"/>
           </a:xfrm>
           <a:prstGeom prst="rect">
             <a:avLst/>
@@ -9626,7 +9631,7 @@
         <p:spPr>
           <a:xfrm>
             <a:off x="566928" y="6364224"/>
-            <a:ext cx="300000" cy="250000"/>
+            <a:ext cx="914400" cy="250000"/>
           </a:xfrm>
           <a:prstGeom prst="rect">
             <a:avLst/>
@@ -9722,7 +9727,7 @@
                 </a:solidFill>
                 <a:latin typeface="Red Hat Text"/>
               </a:rPr>
-              <a:t>ANP · BANP</a:t>
+              <a:t>ADMIN · BASELINE</a:t>
             </a:r>
           </a:p>
         </p:txBody>
@@ -9756,7 +9761,7 @@
                 </a:solidFill>
                 <a:latin typeface="Overpass SemiBold"/>
               </a:rPr>
-              <a:t>AdminNetworkPolicy and BaselineAdminNetworkPolicy</a:t>
+              <a:t>ClusterNetworkPolicy: Admin and Baseline tiers</a:t>
             </a:r>
           </a:p>
         </p:txBody>
@@ -9796,7 +9801,7 @@
                 </a:solidFill>
                 <a:latin typeface="Red Hat Text"/>
               </a:rPr>
-              <a:t>ANP enforces non-negotiable rules: deny traffic to the control plane, allow monitoring agents to scrape all pods, deny cross-environment traffic (dev → prod).</a:t>
+              <a:t>The Admin tier enforces non-negotiable rules: deny traffic to the control plane, accept monitoring agents scraping all pods, deny cross-environment traffic (dev → prod).</a:t>
             </a:r>
           </a:p>
           <a:p>
@@ -9828,7 +9833,7 @@
                 </a:solidFill>
                 <a:latin typeface="Red Hat Text"/>
               </a:rPr>
-              <a:t>BANP is the safety net. Recommended: configure BANP as default-deny. If no ANP and no NP allows the traffic, BANP denies it.</a:t>
+              <a:t>The Baseline tier is the safety net. Recommended: a default-deny Baseline policy. If no Admin rule and no NP allows the traffic, the Baseline tier denies it.</a:t>
             </a:r>
           </a:p>
           <a:p>
@@ -9844,7 +9849,7 @@
                 </a:solidFill>
                 <a:latin typeface="Red Hat Text"/>
               </a:rPr>
-              <a:t>Critical: an ANP with an empty namespace selector ({}) matches all namespaces including openshift-* and kube-system. Use workload-specific label selectors.</a:t>
+              <a:t>Critical: an Admin-tier policy with an empty namespace selector ({}) matches all namespaces including kube-system and the CNI's own. Use workload-specific label selectors.</a:t>
             </a:r>
           </a:p>
         </p:txBody>
@@ -9878,7 +9883,7 @@
                 </a:solidFill>
                 <a:latin typeface="Red Hat Text"/>
               </a:rPr>
-              <a:t>An overly broad ANP can lock the cluster. Use workload-specific labels.</a:t>
+              <a:t>An overly broad Admin-tier policy can lock the cluster. Use workload-specific labels.</a:t>
             </a:r>
           </a:p>
         </p:txBody>
@@ -9892,7 +9897,7 @@
         <p:spPr>
           <a:xfrm>
             <a:off x="566928" y="6364224"/>
-            <a:ext cx="300000" cy="250000"/>
+            <a:ext cx="914400" cy="250000"/>
           </a:xfrm>
           <a:prstGeom prst="rect">
             <a:avLst/>
@@ -10062,7 +10067,7 @@
                 </a:solidFill>
                 <a:latin typeface="Red Hat Text"/>
               </a:rPr>
-              <a:t>ACS-generated baselines: developers review generated policies, not author from scratch. Reviewing a concrete policy is dramatically easier than writing one from zero.</a:t>
+              <a:t>Generated baselines: developers review generated policies, not author from scratch. Reviewing a concrete policy is dramatically easier than writing one from zero.</a:t>
             </a:r>
           </a:p>
           <a:p>
@@ -10094,7 +10099,7 @@
                 </a:solidFill>
                 <a:latin typeface="Red Hat Text"/>
               </a:rPr>
-              <a:t>BANP as safety net: a developer who deploys without any NetworkPolicy gets default-deny automatically. Missing policies become connectivity issues, not security gaps.</a:t>
+              <a:t>The Baseline tier as safety net: a developer who deploys without any NetworkPolicy gets default-deny automatically. Missing policies become connectivity issues, not security gaps.</a:t>
             </a:r>
           </a:p>
           <a:p>
@@ -10110,7 +10115,7 @@
                 </a:solidFill>
                 <a:latin typeface="Red Hat Text"/>
               </a:rPr>
-              <a:t>Golden-path provisioning: new namespaces come with default-deny, EgressFirewall, starter templates, and RBAC bindings pre-installed.</a:t>
+              <a:t>Golden-path provisioning: new namespaces come with default-deny (a Kyverno generate rule), egress rules, starter templates, and RBAC bindings pre-installed.</a:t>
             </a:r>
           </a:p>
         </p:txBody>
@@ -10158,7 +10163,7 @@
         <p:spPr>
           <a:xfrm>
             <a:off x="566928" y="6364224"/>
-            <a:ext cx="300000" cy="250000"/>
+            <a:ext cx="914400" cy="250000"/>
           </a:xfrm>
           <a:prstGeom prst="rect">
             <a:avLst/>

</xml_diff>